<commit_message>
Mobile end-to-end deck: final iOS screenshots, shorter showcase footers
Co-Authored-By: Claude Opus 5.5 <noreply@anthropic.com>
Claude-Session: https://claude.ai/code/session_01RqSYtRwsjzTrt6Ckn2uKQk
</commit_message>
<xml_diff>
--- a/docs/architecture/Lifa-mobile-end-to-end.pptx
+++ b/docs/architecture/Lifa-mobile-end-to-end.pptx
@@ -130,7 +130,7 @@
   <p:extLst>
     <p:ext uri="{521415D9-36F7-43E2-AB2F-B90AF26B5E84}">
       <p14:sectionLst xmlns:p14="http://schemas.microsoft.com/office/powerpoint/2010/main">
-        <p14:section name="Overview" id="{70e95366-0c44-951c-c562-feada6e575ad}">
+        <p14:section name="Overview" id="{7db0c446-ffd8-720e-5bd2-be72742df8b7}">
           <p14:sldIdLst>
             <p14:sldId id="256"/>
             <p14:sldId id="257"/>
@@ -141,14 +141,14 @@
             <p14:sldId id="262"/>
           </p14:sldIdLst>
         </p14:section>
-        <p14:section name="Mobile technology stack" id="{ad069ed9-4e87-2d61-841c-15d576096fcc}">
+        <p14:section name="Mobile technology stack" id="{e6140969-2e54-f122-8c1b-e80eaaf546e1}">
           <p14:sldIdLst>
             <p14:sldId id="263"/>
             <p14:sldId id="264"/>
             <p14:sldId id="265"/>
           </p14:sldIdLst>
         </p14:section>
-        <p14:section name="Journeys 1–6: planning" id="{0ce378bf-7b42-d21c-7a21-b34a7b5f0472}">
+        <p14:section name="Journeys 1–6: planning" id="{eda33244-975f-44a1-43cf-8dc316de229e}">
           <p14:sldIdLst>
             <p14:sldId id="266"/>
             <p14:sldId id="267"/>
@@ -158,7 +158,7 @@
             <p14:sldId id="271"/>
           </p14:sldIdLst>
         </p14:section>
-        <p14:section name="Journeys 7–10: after the owner, and billing" id="{0b0f8796-359d-c72e-201a-438a20125f1e}">
+        <p14:section name="Journeys 7–10: after the owner, and billing" id="{467bce2e-02ba-6c06-429d-8367e45ca616}">
           <p14:sldIdLst>
             <p14:sldId id="272"/>
             <p14:sldId id="273"/>
@@ -166,7 +166,7 @@
             <p14:sldId id="275"/>
           </p14:sldIdLst>
         </p14:section>
-        <p14:section name="More features, security and backend" id="{1e6b0698-7615-19b2-f992-42bddf00cd5a}">
+        <p14:section name="More features, security and backend" id="{ae741e99-3721-dfc7-8350-5ecec2939c86}">
           <p14:sldIdLst>
             <p14:sldId id="276"/>
             <p14:sldId id="277"/>
@@ -22150,7 +22150,7 @@
                   <a:srgbClr val="56625B"/>
                 </a:solidFill>
               </a:rPr>
-              <a:t>iPhone simulator (iOS), SwiftUI app with sample data · status bar set to 9:41 for the capture · demo screens built from the design system; full feature screens follow in step 4 · people and figures are fictional</a:t>
+              <a:t>iPhone simulator (iOS), SwiftUI app with sample data · status bar set to 9:41 for the capture · demo screens with sample data; feature screens follow in step 4</a:t>
             </a:r>
             <a:endParaRPr lang="en-US" sz="1000" dirty="0"/>
           </a:p>
@@ -22772,7 +22772,7 @@
                   <a:srgbClr val="56625B"/>
                 </a:solidFill>
               </a:rPr>
-              <a:t>iPhone simulator (iOS), SwiftUI app with sample data · status bar set to 9:41 for the capture · demo screens built from the design system; full feature screens follow in step 4 · people and figures are fictional</a:t>
+              <a:t>iPhone simulator (iOS), SwiftUI app with sample data · status bar set to 9:41 for the capture · demo screens with sample data; feature screens follow in step 4</a:t>
             </a:r>
             <a:endParaRPr lang="en-US" sz="1000" dirty="0"/>
           </a:p>
@@ -23394,7 +23394,7 @@
                   <a:srgbClr val="56625B"/>
                 </a:solidFill>
               </a:rPr>
-              <a:t>Pixel 7 emulator, Android 14, Google Play build with sample data · Huawei build captured too (docs/design/screens/native-android/hms) · demo screens built from the design system; full feature screens follow in step 4 · people and figures are fictional</a:t>
+              <a:t>Pixel 7 emulator, Android 14, Google Play build · the Huawei build looks identical · demo screens with sample data; feature screens follow in step 4</a:t>
             </a:r>
             <a:endParaRPr lang="en-US" sz="1000" dirty="0"/>
           </a:p>
@@ -24016,7 +24016,7 @@
                   <a:srgbClr val="56625B"/>
                 </a:solidFill>
               </a:rPr>
-              <a:t>Pixel 7 emulator, Android 14, Google Play build with sample data · Huawei build captured too (docs/design/screens/native-android/hms) · demo screens built from the design system; full feature screens follow in step 4 · people and figures are fictional</a:t>
+              <a:t>Pixel 7 emulator, Android 14, Google Play build · the Huawei build looks identical · demo screens with sample data; feature screens follow in step 4</a:t>
             </a:r>
             <a:endParaRPr lang="en-US" sz="1000" dirty="0"/>
           </a:p>

</xml_diff>